<commit_message>
Polish decks: clear overflow warnings, even out lean decks (W6, W11)
- Fix 3 slide-overflow risks (W5 4-col compare -> table, W8 long bullet, W15 long point)
- Add depth slides to the two leanest decks: W11 23->27, W6 25->28
- All decks now lint-clean and in a 27-37 slide band

Co-Authored-By: Claude Opus 4.8 <noreply@anthropic.com>
Claude-Session: https://claude.ai/code/session_012jACa3xvaCp9Yvx3Z8JvKT
</commit_message>
<xml_diff>
--- a/Causal_Inference_Course/Week05_Regression_Adjustment/Week05_Regression_Adjustment_Lecture.pptx
+++ b/Causal_Inference_Course/Week05_Regression_Adjustment/Week05_Regression_Adjustment_Lecture.pptx
@@ -5204,149 +5204,474 @@
           </a:p>
         </p:txBody>
       </p:sp>
-      <p:sp>
-        <p:nvSpPr>
-          <p:cNvPr id="5" name="Rectangle 4"/>
-          <p:cNvSpPr/>
-          <p:nvPr/>
-        </p:nvSpPr>
-        <p:spPr>
-          <a:xfrm>
-            <a:off x="548640" y="1920240"/>
-            <a:ext cx="2560320" cy="4297680"/>
-          </a:xfrm>
-          <a:prstGeom prst="rect">
-            <a:avLst/>
-          </a:prstGeom>
-          <a:solidFill>
-            <a:srgbClr val="ECEEF2"/>
-          </a:solidFill>
-          <a:ln>
-            <a:noFill/>
-          </a:ln>
-          <a:effectLst/>
-        </p:spPr>
-        <p:style>
-          <a:lnRef idx="1">
-            <a:schemeClr val="accent1"/>
-          </a:lnRef>
-          <a:fillRef idx="3">
-            <a:schemeClr val="accent1"/>
-          </a:fillRef>
-          <a:effectRef idx="2">
-            <a:schemeClr val="accent1"/>
-          </a:effectRef>
-          <a:fontRef idx="minor">
-            <a:schemeClr val="lt1"/>
-          </a:fontRef>
-        </p:style>
-        <p:txBody>
-          <a:bodyPr rtlCol="0" anchor="ctr"/>
-          <a:lstStyle/>
-          <a:p>
-            <a:pPr algn="ctr"/>
-          </a:p>
-        </p:txBody>
-      </p:sp>
-      <p:sp>
-        <p:nvSpPr>
-          <p:cNvPr id="6" name="Rectangle 5"/>
-          <p:cNvSpPr/>
-          <p:nvPr/>
-        </p:nvSpPr>
-        <p:spPr>
-          <a:xfrm>
-            <a:off x="548640" y="1920240"/>
-            <a:ext cx="2560320" cy="640080"/>
-          </a:xfrm>
-          <a:prstGeom prst="rect">
-            <a:avLst/>
-          </a:prstGeom>
-          <a:solidFill>
-            <a:srgbClr val="2F6DB5"/>
-          </a:solidFill>
-          <a:ln>
-            <a:noFill/>
-          </a:ln>
-          <a:effectLst/>
-        </p:spPr>
-        <p:style>
-          <a:lnRef idx="1">
-            <a:schemeClr val="accent1"/>
-          </a:lnRef>
-          <a:fillRef idx="3">
-            <a:schemeClr val="accent1"/>
-          </a:fillRef>
-          <a:effectRef idx="2">
-            <a:schemeClr val="accent1"/>
-          </a:effectRef>
-          <a:fontRef idx="minor">
-            <a:schemeClr val="lt1"/>
-          </a:fontRef>
-        </p:style>
-        <p:txBody>
-          <a:bodyPr rtlCol="0" anchor="ctr"/>
-          <a:lstStyle/>
-          <a:p>
-            <a:pPr algn="ctr"/>
-          </a:p>
-        </p:txBody>
-      </p:sp>
-      <p:sp>
-        <p:nvSpPr>
-          <p:cNvPr id="7" name="TextBox 6"/>
+      <p:graphicFrame>
+        <p:nvGraphicFramePr>
+          <p:cNvPr id="5" name="Table 4"/>
+          <p:cNvGraphicFramePr>
+            <a:graphicFrameLocks noGrp="1"/>
+          </p:cNvGraphicFramePr>
+          <p:nvPr/>
+        </p:nvGraphicFramePr>
+        <p:xfrm>
+          <a:off x="548640" y="1920240"/>
+          <a:ext cx="11064240" cy="2286000"/>
+        </p:xfrm>
+        <a:graphic>
+          <a:graphicData uri="http://schemas.openxmlformats.org/drawingml/2006/table">
+            <a:tbl>
+              <a:tblPr bandRow="1">
+                <a:tableStyleId>{5C22544A-7EE6-4342-B048-85BDC9FD1C3A}</a:tableStyleId>
+              </a:tblPr>
+              <a:tblGrid>
+                <a:gridCol w="2766060"/>
+                <a:gridCol w="2766060"/>
+                <a:gridCol w="2766060"/>
+                <a:gridCol w="2766060"/>
+              </a:tblGrid>
+              <a:tr h="457200">
+                <a:tc>
+                  <a:txBody>
+                    <a:bodyPr/>
+                    <a:lstStyle/>
+                    <a:p>
+                      <a:r>
+                        <a:rPr sz="1400" b="1">
+                          <a:solidFill>
+                            <a:srgbClr val="FFFFFF"/>
+                          </a:solidFill>
+                        </a:rPr>
+                        <a:t>Role</a:t>
+                      </a:r>
+                    </a:p>
+                  </a:txBody>
+                  <a:tcPr>
+                    <a:solidFill>
+                      <a:srgbClr val="1F2A44"/>
+                    </a:solidFill>
+                  </a:tcPr>
+                </a:tc>
+                <a:tc>
+                  <a:txBody>
+                    <a:bodyPr/>
+                    <a:lstStyle/>
+                    <a:p>
+                      <a:r>
+                        <a:rPr sz="1400" b="1">
+                          <a:solidFill>
+                            <a:srgbClr val="FFFFFF"/>
+                          </a:solidFill>
+                        </a:rPr>
+                        <a:t>Structure</a:t>
+                      </a:r>
+                    </a:p>
+                  </a:txBody>
+                  <a:tcPr>
+                    <a:solidFill>
+                      <a:srgbClr val="1F2A44"/>
+                    </a:solidFill>
+                  </a:tcPr>
+                </a:tc>
+                <a:tc>
+                  <a:txBody>
+                    <a:bodyPr/>
+                    <a:lstStyle/>
+                    <a:p>
+                      <a:r>
+                        <a:rPr sz="1400" b="1">
+                          <a:solidFill>
+                            <a:srgbClr val="FFFFFF"/>
+                          </a:solidFill>
+                        </a:rPr>
+                        <a:t>Adjust?</a:t>
+                      </a:r>
+                    </a:p>
+                  </a:txBody>
+                  <a:tcPr>
+                    <a:solidFill>
+                      <a:srgbClr val="1F2A44"/>
+                    </a:solidFill>
+                  </a:tcPr>
+                </a:tc>
+                <a:tc>
+                  <a:txBody>
+                    <a:bodyPr/>
+                    <a:lstStyle/>
+                    <a:p>
+                      <a:r>
+                        <a:rPr sz="1400" b="1">
+                          <a:solidFill>
+                            <a:srgbClr val="FFFFFF"/>
+                          </a:solidFill>
+                        </a:rPr>
+                        <a:t>What adjusting does</a:t>
+                      </a:r>
+                    </a:p>
+                  </a:txBody>
+                  <a:tcPr>
+                    <a:solidFill>
+                      <a:srgbClr val="1F2A44"/>
+                    </a:solidFill>
+                  </a:tcPr>
+                </a:tc>
+              </a:tr>
+              <a:tr h="457200">
+                <a:tc>
+                  <a:txBody>
+                    <a:bodyPr/>
+                    <a:lstStyle/>
+                    <a:p>
+                      <a:r>
+                        <a:rPr sz="1300" b="1">
+                          <a:solidFill>
+                            <a:srgbClr val="222732"/>
+                          </a:solidFill>
+                        </a:rPr>
+                        <a:t>Good control (confounder)</a:t>
+                      </a:r>
+                    </a:p>
+                  </a:txBody>
+                  <a:tcPr>
+                    <a:solidFill>
+                      <a:srgbClr val="FFFFFF"/>
+                    </a:solidFill>
+                  </a:tcPr>
+                </a:tc>
+                <a:tc>
+                  <a:txBody>
+                    <a:bodyPr/>
+                    <a:lstStyle/>
+                    <a:p>
+                      <a:r>
+                        <a:rPr sz="1300">
+                          <a:solidFill>
+                            <a:srgbClr val="222732"/>
+                          </a:solidFill>
+                        </a:rPr>
+                        <a:t>Z → X and Z → Y</a:t>
+                      </a:r>
+                    </a:p>
+                  </a:txBody>
+                  <a:tcPr>
+                    <a:solidFill>
+                      <a:srgbClr val="FFFFFF"/>
+                    </a:solidFill>
+                  </a:tcPr>
+                </a:tc>
+                <a:tc>
+                  <a:txBody>
+                    <a:bodyPr/>
+                    <a:lstStyle/>
+                    <a:p>
+                      <a:r>
+                        <a:rPr sz="1300">
+                          <a:solidFill>
+                            <a:srgbClr val="222732"/>
+                          </a:solidFill>
+                        </a:rPr>
+                        <a:t>Yes</a:t>
+                      </a:r>
+                    </a:p>
+                  </a:txBody>
+                  <a:tcPr>
+                    <a:solidFill>
+                      <a:srgbClr val="FFFFFF"/>
+                    </a:solidFill>
+                  </a:tcPr>
+                </a:tc>
+                <a:tc>
+                  <a:txBody>
+                    <a:bodyPr/>
+                    <a:lstStyle/>
+                    <a:p>
+                      <a:r>
+                        <a:rPr sz="1300">
+                          <a:solidFill>
+                            <a:srgbClr val="222732"/>
+                          </a:solidFill>
+                        </a:rPr>
+                        <a:t>Closes a back-door path — removes bias.</a:t>
+                      </a:r>
+                    </a:p>
+                  </a:txBody>
+                  <a:tcPr>
+                    <a:solidFill>
+                      <a:srgbClr val="FFFFFF"/>
+                    </a:solidFill>
+                  </a:tcPr>
+                </a:tc>
+              </a:tr>
+              <a:tr h="457200">
+                <a:tc>
+                  <a:txBody>
+                    <a:bodyPr/>
+                    <a:lstStyle/>
+                    <a:p>
+                      <a:r>
+                        <a:rPr sz="1300" b="1">
+                          <a:solidFill>
+                            <a:srgbClr val="222732"/>
+                          </a:solidFill>
+                        </a:rPr>
+                        <a:t>Bad control (mediator)</a:t>
+                      </a:r>
+                    </a:p>
+                  </a:txBody>
+                  <a:tcPr>
+                    <a:solidFill>
+                      <a:srgbClr val="ECEEF2"/>
+                    </a:solidFill>
+                  </a:tcPr>
+                </a:tc>
+                <a:tc>
+                  <a:txBody>
+                    <a:bodyPr/>
+                    <a:lstStyle/>
+                    <a:p>
+                      <a:r>
+                        <a:rPr sz="1300">
+                          <a:solidFill>
+                            <a:srgbClr val="222732"/>
+                          </a:solidFill>
+                        </a:rPr>
+                        <a:t>X → M → Y</a:t>
+                      </a:r>
+                    </a:p>
+                  </a:txBody>
+                  <a:tcPr>
+                    <a:solidFill>
+                      <a:srgbClr val="ECEEF2"/>
+                    </a:solidFill>
+                  </a:tcPr>
+                </a:tc>
+                <a:tc>
+                  <a:txBody>
+                    <a:bodyPr/>
+                    <a:lstStyle/>
+                    <a:p>
+                      <a:r>
+                        <a:rPr sz="1300">
+                          <a:solidFill>
+                            <a:srgbClr val="222732"/>
+                          </a:solidFill>
+                        </a:rPr>
+                        <a:t>No</a:t>
+                      </a:r>
+                    </a:p>
+                  </a:txBody>
+                  <a:tcPr>
+                    <a:solidFill>
+                      <a:srgbClr val="ECEEF2"/>
+                    </a:solidFill>
+                  </a:tcPr>
+                </a:tc>
+                <a:tc>
+                  <a:txBody>
+                    <a:bodyPr/>
+                    <a:lstStyle/>
+                    <a:p>
+                      <a:r>
+                        <a:rPr sz="1300">
+                          <a:solidFill>
+                            <a:srgbClr val="222732"/>
+                          </a:solidFill>
+                        </a:rPr>
+                        <a:t>Blocks the very effect you want.</a:t>
+                      </a:r>
+                    </a:p>
+                  </a:txBody>
+                  <a:tcPr>
+                    <a:solidFill>
+                      <a:srgbClr val="ECEEF2"/>
+                    </a:solidFill>
+                  </a:tcPr>
+                </a:tc>
+              </a:tr>
+              <a:tr h="457200">
+                <a:tc>
+                  <a:txBody>
+                    <a:bodyPr/>
+                    <a:lstStyle/>
+                    <a:p>
+                      <a:r>
+                        <a:rPr sz="1300" b="1">
+                          <a:solidFill>
+                            <a:srgbClr val="222732"/>
+                          </a:solidFill>
+                        </a:rPr>
+                        <a:t>Collider (common effect)</a:t>
+                      </a:r>
+                    </a:p>
+                  </a:txBody>
+                  <a:tcPr>
+                    <a:solidFill>
+                      <a:srgbClr val="FFFFFF"/>
+                    </a:solidFill>
+                  </a:tcPr>
+                </a:tc>
+                <a:tc>
+                  <a:txBody>
+                    <a:bodyPr/>
+                    <a:lstStyle/>
+                    <a:p>
+                      <a:r>
+                        <a:rPr sz="1300">
+                          <a:solidFill>
+                            <a:srgbClr val="222732"/>
+                          </a:solidFill>
+                        </a:rPr>
+                        <a:t>X → K ← Y</a:t>
+                      </a:r>
+                    </a:p>
+                  </a:txBody>
+                  <a:tcPr>
+                    <a:solidFill>
+                      <a:srgbClr val="FFFFFF"/>
+                    </a:solidFill>
+                  </a:tcPr>
+                </a:tc>
+                <a:tc>
+                  <a:txBody>
+                    <a:bodyPr/>
+                    <a:lstStyle/>
+                    <a:p>
+                      <a:r>
+                        <a:rPr sz="1300">
+                          <a:solidFill>
+                            <a:srgbClr val="222732"/>
+                          </a:solidFill>
+                        </a:rPr>
+                        <a:t>No</a:t>
+                      </a:r>
+                    </a:p>
+                  </a:txBody>
+                  <a:tcPr>
+                    <a:solidFill>
+                      <a:srgbClr val="FFFFFF"/>
+                    </a:solidFill>
+                  </a:tcPr>
+                </a:tc>
+                <a:tc>
+                  <a:txBody>
+                    <a:bodyPr/>
+                    <a:lstStyle/>
+                    <a:p>
+                      <a:r>
+                        <a:rPr sz="1300">
+                          <a:solidFill>
+                            <a:srgbClr val="222732"/>
+                          </a:solidFill>
+                        </a:rPr>
+                        <a:t>Opens a spurious path — adds bias.</a:t>
+                      </a:r>
+                    </a:p>
+                  </a:txBody>
+                  <a:tcPr>
+                    <a:solidFill>
+                      <a:srgbClr val="FFFFFF"/>
+                    </a:solidFill>
+                  </a:tcPr>
+                </a:tc>
+              </a:tr>
+              <a:tr h="457200">
+                <a:tc>
+                  <a:txBody>
+                    <a:bodyPr/>
+                    <a:lstStyle/>
+                    <a:p>
+                      <a:r>
+                        <a:rPr sz="1300" b="1">
+                          <a:solidFill>
+                            <a:srgbClr val="222732"/>
+                          </a:solidFill>
+                        </a:rPr>
+                        <a:t>Neutral (outcome predictor)</a:t>
+                      </a:r>
+                    </a:p>
+                  </a:txBody>
+                  <a:tcPr>
+                    <a:solidFill>
+                      <a:srgbClr val="ECEEF2"/>
+                    </a:solidFill>
+                  </a:tcPr>
+                </a:tc>
+                <a:tc>
+                  <a:txBody>
+                    <a:bodyPr/>
+                    <a:lstStyle/>
+                    <a:p>
+                      <a:r>
+                        <a:rPr sz="1300">
+                          <a:solidFill>
+                            <a:srgbClr val="222732"/>
+                          </a:solidFill>
+                        </a:rPr>
+                        <a:t>Z → Y only</a:t>
+                      </a:r>
+                    </a:p>
+                  </a:txBody>
+                  <a:tcPr>
+                    <a:solidFill>
+                      <a:srgbClr val="ECEEF2"/>
+                    </a:solidFill>
+                  </a:tcPr>
+                </a:tc>
+                <a:tc>
+                  <a:txBody>
+                    <a:bodyPr/>
+                    <a:lstStyle/>
+                    <a:p>
+                      <a:r>
+                        <a:rPr sz="1300">
+                          <a:solidFill>
+                            <a:srgbClr val="222732"/>
+                          </a:solidFill>
+                        </a:rPr>
+                        <a:t>Optional</a:t>
+                      </a:r>
+                    </a:p>
+                  </a:txBody>
+                  <a:tcPr>
+                    <a:solidFill>
+                      <a:srgbClr val="ECEEF2"/>
+                    </a:solidFill>
+                  </a:tcPr>
+                </a:tc>
+                <a:tc>
+                  <a:txBody>
+                    <a:bodyPr/>
+                    <a:lstStyle/>
+                    <a:p>
+                      <a:r>
+                        <a:rPr sz="1300">
+                          <a:solidFill>
+                            <a:srgbClr val="222732"/>
+                          </a:solidFill>
+                        </a:rPr>
+                        <a:t>Off every back-door — only lowers variance.</a:t>
+                      </a:r>
+                    </a:p>
+                  </a:txBody>
+                  <a:tcPr>
+                    <a:solidFill>
+                      <a:srgbClr val="ECEEF2"/>
+                    </a:solidFill>
+                  </a:tcPr>
+                </a:tc>
+              </a:tr>
+            </a:tbl>
+          </a:graphicData>
+        </a:graphic>
+      </p:graphicFrame>
+      <p:sp>
+        <p:nvSpPr>
+          <p:cNvPr id="6" name="TextBox 5"/>
           <p:cNvSpPr txBox="1"/>
           <p:nvPr/>
         </p:nvSpPr>
         <p:spPr>
           <a:xfrm>
-            <a:off x="731520" y="2029968"/>
-            <a:ext cx="2194560" cy="457200"/>
-          </a:xfrm>
-          <a:prstGeom prst="rect">
-            <a:avLst/>
-          </a:prstGeom>
-          <a:noFill/>
-        </p:spPr>
-        <p:txBody>
-          <a:bodyPr wrap="square" anchor="ctr" lIns="0" rIns="0" tIns="0" bIns="0">
-            <a:spAutoFit/>
-          </a:bodyPr>
-          <a:lstStyle/>
-          <a:p>
-            <a:pPr algn="l">
-              <a:lnSpc>
-                <a:spcPct val="100000"/>
-              </a:lnSpc>
-              <a:spcBef>
-                <a:spcPts val="0"/>
-              </a:spcBef>
-              <a:spcAft>
-                <a:spcPts val="400"/>
-              </a:spcAft>
-            </a:pPr>
-            <a:r>
-              <a:rPr sz="1700" b="1" i="0">
-                <a:solidFill>
-                  <a:srgbClr val="FFFFFF"/>
-                </a:solidFill>
-                <a:latin typeface="Calibri"/>
-              </a:rPr>
-              <a:t>Good control</a:t>
-            </a:r>
-          </a:p>
-        </p:txBody>
-      </p:sp>
-      <p:sp>
-        <p:nvSpPr>
-          <p:cNvPr id="8" name="TextBox 7"/>
-          <p:cNvSpPr txBox="1"/>
-          <p:nvPr/>
-        </p:nvSpPr>
-        <p:spPr>
-          <a:xfrm>
-            <a:off x="731520" y="2697480"/>
-            <a:ext cx="2194560" cy="457200"/>
+            <a:off x="548640" y="5715000"/>
+            <a:ext cx="11064240" cy="731520"/>
           </a:xfrm>
           <a:prstGeom prst="rect">
             <a:avLst/>
@@ -5371,1018 +5696,29 @@
               </a:spcAft>
             </a:pPr>
             <a:r>
-              <a:rPr sz="1400" b="1" i="1">
-                <a:solidFill>
-                  <a:srgbClr val="2F6DB5"/>
-                </a:solidFill>
-                <a:latin typeface="Calibri"/>
-              </a:rPr>
-              <a:t>confounder</a:t>
-            </a:r>
-          </a:p>
-        </p:txBody>
-      </p:sp>
-      <p:sp>
-        <p:nvSpPr>
-          <p:cNvPr id="9" name="TextBox 8"/>
-          <p:cNvSpPr txBox="1"/>
-          <p:nvPr/>
-        </p:nvSpPr>
-        <p:spPr>
-          <a:xfrm>
-            <a:off x="731520" y="3200400"/>
-            <a:ext cx="2194560" cy="2743200"/>
-          </a:xfrm>
-          <a:prstGeom prst="rect">
-            <a:avLst/>
-          </a:prstGeom>
-          <a:noFill/>
-        </p:spPr>
-        <p:txBody>
-          <a:bodyPr wrap="square" anchor="t" lIns="0" rIns="0" tIns="0" bIns="0">
-            <a:spAutoFit/>
-          </a:bodyPr>
-          <a:lstStyle/>
-          <a:p>
-            <a:pPr algn="l">
-              <a:lnSpc>
-                <a:spcPct val="100000"/>
-              </a:lnSpc>
-              <a:spcBef>
-                <a:spcPts val="0"/>
-              </a:spcBef>
-              <a:spcAft>
-                <a:spcPts val="700"/>
-              </a:spcAft>
-            </a:pPr>
-            <a:r>
-              <a:rPr sz="1800" b="1" i="0">
-                <a:solidFill>
-                  <a:srgbClr val="E9A23B"/>
-                </a:solidFill>
-                <a:latin typeface="Calibri"/>
-              </a:rPr>
-              <a:t>—  </a:t>
-            </a:r>
-            <a:r>
-              <a:rPr sz="1800" b="0" i="0">
+              <a:rPr sz="1400" b="1" i="0">
+                <a:solidFill>
+                  <a:srgbClr val="2A9D8F"/>
+                </a:solidFill>
+                <a:latin typeface="Calibri"/>
+              </a:rPr>
+              <a:t>The one rule:  </a:t>
+            </a:r>
+            <a:r>
+              <a:rPr sz="1400" b="0" i="0">
                 <a:solidFill>
                   <a:srgbClr val="222732"/>
                 </a:solidFill>
                 <a:latin typeface="Calibri"/>
               </a:rPr>
-              <a:t>Z → X and Z → Y.</a:t>
-            </a:r>
-          </a:p>
-          <a:p>
-            <a:pPr algn="l">
-              <a:lnSpc>
-                <a:spcPct val="100000"/>
-              </a:lnSpc>
-              <a:spcBef>
-                <a:spcPts val="0"/>
-              </a:spcBef>
-              <a:spcAft>
-                <a:spcPts val="700"/>
-              </a:spcAft>
-            </a:pPr>
-            <a:r>
-              <a:rPr sz="1800" b="1" i="0">
-                <a:solidFill>
-                  <a:srgbClr val="E9A23B"/>
-                </a:solidFill>
-                <a:latin typeface="Calibri"/>
-              </a:rPr>
-              <a:t>—  </a:t>
-            </a:r>
-            <a:r>
-              <a:rPr sz="1800" b="0" i="0">
-                <a:solidFill>
-                  <a:srgbClr val="222732"/>
-                </a:solidFill>
-                <a:latin typeface="Calibri"/>
-              </a:rPr>
-              <a:t>Opens a back-door path.</a:t>
-            </a:r>
-          </a:p>
-          <a:p>
-            <a:pPr algn="l">
-              <a:lnSpc>
-                <a:spcPct val="100000"/>
-              </a:lnSpc>
-              <a:spcBef>
-                <a:spcPts val="0"/>
-              </a:spcBef>
-              <a:spcAft>
-                <a:spcPts val="700"/>
-              </a:spcAft>
-            </a:pPr>
-            <a:r>
-              <a:rPr sz="1800" b="1" i="0">
-                <a:solidFill>
-                  <a:srgbClr val="E9A23B"/>
-                </a:solidFill>
-                <a:latin typeface="Calibri"/>
-              </a:rPr>
-              <a:t>—  </a:t>
-            </a:r>
-            <a:r>
-              <a:rPr sz="1800" b="0" i="0">
-                <a:solidFill>
-                  <a:srgbClr val="222732"/>
-                </a:solidFill>
-                <a:latin typeface="Calibri"/>
-              </a:rPr>
-              <a:t>ADJUST — removes bias.</a:t>
-            </a:r>
-          </a:p>
-        </p:txBody>
-      </p:sp>
-      <p:sp>
-        <p:nvSpPr>
-          <p:cNvPr id="10" name="Rectangle 9"/>
-          <p:cNvSpPr/>
-          <p:nvPr/>
-        </p:nvSpPr>
-        <p:spPr>
-          <a:xfrm>
-            <a:off x="3383280" y="1920240"/>
-            <a:ext cx="2560320" cy="4297680"/>
-          </a:xfrm>
-          <a:prstGeom prst="rect">
-            <a:avLst/>
-          </a:prstGeom>
-          <a:solidFill>
-            <a:srgbClr val="ECEEF2"/>
-          </a:solidFill>
-          <a:ln>
-            <a:noFill/>
-          </a:ln>
-          <a:effectLst/>
-        </p:spPr>
-        <p:style>
-          <a:lnRef idx="1">
-            <a:schemeClr val="accent1"/>
-          </a:lnRef>
-          <a:fillRef idx="3">
-            <a:schemeClr val="accent1"/>
-          </a:fillRef>
-          <a:effectRef idx="2">
-            <a:schemeClr val="accent1"/>
-          </a:effectRef>
-          <a:fontRef idx="minor">
-            <a:schemeClr val="lt1"/>
-          </a:fontRef>
-        </p:style>
-        <p:txBody>
-          <a:bodyPr rtlCol="0" anchor="ctr"/>
-          <a:lstStyle/>
-          <a:p>
-            <a:pPr algn="ctr"/>
-          </a:p>
-        </p:txBody>
-      </p:sp>
-      <p:sp>
-        <p:nvSpPr>
-          <p:cNvPr id="11" name="Rectangle 10"/>
-          <p:cNvSpPr/>
-          <p:nvPr/>
-        </p:nvSpPr>
-        <p:spPr>
-          <a:xfrm>
-            <a:off x="3383280" y="1920240"/>
-            <a:ext cx="2560320" cy="640080"/>
-          </a:xfrm>
-          <a:prstGeom prst="rect">
-            <a:avLst/>
-          </a:prstGeom>
-          <a:solidFill>
-            <a:srgbClr val="2A9D8F"/>
-          </a:solidFill>
-          <a:ln>
-            <a:noFill/>
-          </a:ln>
-          <a:effectLst/>
-        </p:spPr>
-        <p:style>
-          <a:lnRef idx="1">
-            <a:schemeClr val="accent1"/>
-          </a:lnRef>
-          <a:fillRef idx="3">
-            <a:schemeClr val="accent1"/>
-          </a:fillRef>
-          <a:effectRef idx="2">
-            <a:schemeClr val="accent1"/>
-          </a:effectRef>
-          <a:fontRef idx="minor">
-            <a:schemeClr val="lt1"/>
-          </a:fontRef>
-        </p:style>
-        <p:txBody>
-          <a:bodyPr rtlCol="0" anchor="ctr"/>
-          <a:lstStyle/>
-          <a:p>
-            <a:pPr algn="ctr"/>
-          </a:p>
-        </p:txBody>
-      </p:sp>
-      <p:sp>
-        <p:nvSpPr>
-          <p:cNvPr id="12" name="TextBox 11"/>
-          <p:cNvSpPr txBox="1"/>
-          <p:nvPr/>
-        </p:nvSpPr>
-        <p:spPr>
-          <a:xfrm>
-            <a:off x="3566160" y="2029968"/>
-            <a:ext cx="2194560" cy="457200"/>
-          </a:xfrm>
-          <a:prstGeom prst="rect">
-            <a:avLst/>
-          </a:prstGeom>
-          <a:noFill/>
-        </p:spPr>
-        <p:txBody>
-          <a:bodyPr wrap="square" anchor="ctr" lIns="0" rIns="0" tIns="0" bIns="0">
-            <a:spAutoFit/>
-          </a:bodyPr>
-          <a:lstStyle/>
-          <a:p>
-            <a:pPr algn="l">
-              <a:lnSpc>
-                <a:spcPct val="100000"/>
-              </a:lnSpc>
-              <a:spcBef>
-                <a:spcPts val="0"/>
-              </a:spcBef>
-              <a:spcAft>
-                <a:spcPts val="400"/>
-              </a:spcAft>
-            </a:pPr>
-            <a:r>
-              <a:rPr sz="1700" b="1" i="0">
-                <a:solidFill>
-                  <a:srgbClr val="FFFFFF"/>
-                </a:solidFill>
-                <a:latin typeface="Calibri"/>
-              </a:rPr>
-              <a:t>Bad control</a:t>
-            </a:r>
-          </a:p>
-        </p:txBody>
-      </p:sp>
-      <p:sp>
-        <p:nvSpPr>
-          <p:cNvPr id="13" name="TextBox 12"/>
-          <p:cNvSpPr txBox="1"/>
-          <p:nvPr/>
-        </p:nvSpPr>
-        <p:spPr>
-          <a:xfrm>
-            <a:off x="3566160" y="2697480"/>
-            <a:ext cx="2194560" cy="457200"/>
-          </a:xfrm>
-          <a:prstGeom prst="rect">
-            <a:avLst/>
-          </a:prstGeom>
-          <a:noFill/>
-        </p:spPr>
-        <p:txBody>
-          <a:bodyPr wrap="square" anchor="t" lIns="0" rIns="0" tIns="0" bIns="0">
-            <a:spAutoFit/>
-          </a:bodyPr>
-          <a:lstStyle/>
-          <a:p>
-            <a:pPr algn="l">
-              <a:lnSpc>
-                <a:spcPct val="100000"/>
-              </a:lnSpc>
-              <a:spcBef>
-                <a:spcPts val="0"/>
-              </a:spcBef>
-              <a:spcAft>
-                <a:spcPts val="400"/>
-              </a:spcAft>
-            </a:pPr>
-            <a:r>
-              <a:rPr sz="1400" b="1" i="1">
-                <a:solidFill>
-                  <a:srgbClr val="2A9D8F"/>
-                </a:solidFill>
-                <a:latin typeface="Calibri"/>
-              </a:rPr>
-              <a:t>mediator</a:t>
-            </a:r>
-          </a:p>
-        </p:txBody>
-      </p:sp>
-      <p:sp>
-        <p:nvSpPr>
-          <p:cNvPr id="14" name="TextBox 13"/>
-          <p:cNvSpPr txBox="1"/>
-          <p:nvPr/>
-        </p:nvSpPr>
-        <p:spPr>
-          <a:xfrm>
-            <a:off x="3566160" y="3200400"/>
-            <a:ext cx="2194560" cy="2743200"/>
-          </a:xfrm>
-          <a:prstGeom prst="rect">
-            <a:avLst/>
-          </a:prstGeom>
-          <a:noFill/>
-        </p:spPr>
-        <p:txBody>
-          <a:bodyPr wrap="square" anchor="t" lIns="0" rIns="0" tIns="0" bIns="0">
-            <a:spAutoFit/>
-          </a:bodyPr>
-          <a:lstStyle/>
-          <a:p>
-            <a:pPr algn="l">
-              <a:lnSpc>
-                <a:spcPct val="100000"/>
-              </a:lnSpc>
-              <a:spcBef>
-                <a:spcPts val="0"/>
-              </a:spcBef>
-              <a:spcAft>
-                <a:spcPts val="700"/>
-              </a:spcAft>
-            </a:pPr>
-            <a:r>
-              <a:rPr sz="1800" b="1" i="0">
-                <a:solidFill>
-                  <a:srgbClr val="E9A23B"/>
-                </a:solidFill>
-                <a:latin typeface="Calibri"/>
-              </a:rPr>
-              <a:t>—  </a:t>
-            </a:r>
-            <a:r>
-              <a:rPr sz="1800" b="0" i="0">
-                <a:solidFill>
-                  <a:srgbClr val="222732"/>
-                </a:solidFill>
-                <a:latin typeface="Calibri"/>
-              </a:rPr>
-              <a:t>X → M → Y.</a:t>
-            </a:r>
-          </a:p>
-          <a:p>
-            <a:pPr algn="l">
-              <a:lnSpc>
-                <a:spcPct val="100000"/>
-              </a:lnSpc>
-              <a:spcBef>
-                <a:spcPts val="0"/>
-              </a:spcBef>
-              <a:spcAft>
-                <a:spcPts val="700"/>
-              </a:spcAft>
-            </a:pPr>
-            <a:r>
-              <a:rPr sz="1800" b="1" i="0">
-                <a:solidFill>
-                  <a:srgbClr val="E9A23B"/>
-                </a:solidFill>
-                <a:latin typeface="Calibri"/>
-              </a:rPr>
-              <a:t>—  </a:t>
-            </a:r>
-            <a:r>
-              <a:rPr sz="1800" b="0" i="0">
-                <a:solidFill>
-                  <a:srgbClr val="222732"/>
-                </a:solidFill>
-                <a:latin typeface="Calibri"/>
-              </a:rPr>
-              <a:t>On the causal path.</a:t>
-            </a:r>
-          </a:p>
-          <a:p>
-            <a:pPr algn="l">
-              <a:lnSpc>
-                <a:spcPct val="100000"/>
-              </a:lnSpc>
-              <a:spcBef>
-                <a:spcPts val="0"/>
-              </a:spcBef>
-              <a:spcAft>
-                <a:spcPts val="700"/>
-              </a:spcAft>
-            </a:pPr>
-            <a:r>
-              <a:rPr sz="1800" b="1" i="0">
-                <a:solidFill>
-                  <a:srgbClr val="E9A23B"/>
-                </a:solidFill>
-                <a:latin typeface="Calibri"/>
-              </a:rPr>
-              <a:t>—  </a:t>
-            </a:r>
-            <a:r>
-              <a:rPr sz="1800" b="0" i="0">
-                <a:solidFill>
-                  <a:srgbClr val="222732"/>
-                </a:solidFill>
-                <a:latin typeface="Calibri"/>
-              </a:rPr>
-              <a:t>DON'T — blocks the effect.</a:t>
-            </a:r>
-          </a:p>
-        </p:txBody>
-      </p:sp>
-      <p:sp>
-        <p:nvSpPr>
-          <p:cNvPr id="15" name="Rectangle 14"/>
-          <p:cNvSpPr/>
-          <p:nvPr/>
-        </p:nvSpPr>
-        <p:spPr>
-          <a:xfrm>
-            <a:off x="6217920" y="1920240"/>
-            <a:ext cx="2560320" cy="4297680"/>
-          </a:xfrm>
-          <a:prstGeom prst="rect">
-            <a:avLst/>
-          </a:prstGeom>
-          <a:solidFill>
-            <a:srgbClr val="ECEEF2"/>
-          </a:solidFill>
-          <a:ln>
-            <a:noFill/>
-          </a:ln>
-          <a:effectLst/>
-        </p:spPr>
-        <p:style>
-          <a:lnRef idx="1">
-            <a:schemeClr val="accent1"/>
-          </a:lnRef>
-          <a:fillRef idx="3">
-            <a:schemeClr val="accent1"/>
-          </a:fillRef>
-          <a:effectRef idx="2">
-            <a:schemeClr val="accent1"/>
-          </a:effectRef>
-          <a:fontRef idx="minor">
-            <a:schemeClr val="lt1"/>
-          </a:fontRef>
-        </p:style>
-        <p:txBody>
-          <a:bodyPr rtlCol="0" anchor="ctr"/>
-          <a:lstStyle/>
-          <a:p>
-            <a:pPr algn="ctr"/>
-          </a:p>
-        </p:txBody>
-      </p:sp>
-      <p:sp>
-        <p:nvSpPr>
-          <p:cNvPr id="16" name="Rectangle 15"/>
-          <p:cNvSpPr/>
-          <p:nvPr/>
-        </p:nvSpPr>
-        <p:spPr>
-          <a:xfrm>
-            <a:off x="6217920" y="1920240"/>
-            <a:ext cx="2560320" cy="640080"/>
-          </a:xfrm>
-          <a:prstGeom prst="rect">
-            <a:avLst/>
-          </a:prstGeom>
-          <a:solidFill>
-            <a:srgbClr val="E9A23B"/>
-          </a:solidFill>
-          <a:ln>
-            <a:noFill/>
-          </a:ln>
-          <a:effectLst/>
-        </p:spPr>
-        <p:style>
-          <a:lnRef idx="1">
-            <a:schemeClr val="accent1"/>
-          </a:lnRef>
-          <a:fillRef idx="3">
-            <a:schemeClr val="accent1"/>
-          </a:fillRef>
-          <a:effectRef idx="2">
-            <a:schemeClr val="accent1"/>
-          </a:effectRef>
-          <a:fontRef idx="minor">
-            <a:schemeClr val="lt1"/>
-          </a:fontRef>
-        </p:style>
-        <p:txBody>
-          <a:bodyPr rtlCol="0" anchor="ctr"/>
-          <a:lstStyle/>
-          <a:p>
-            <a:pPr algn="ctr"/>
-          </a:p>
-        </p:txBody>
-      </p:sp>
-      <p:sp>
-        <p:nvSpPr>
-          <p:cNvPr id="17" name="TextBox 16"/>
-          <p:cNvSpPr txBox="1"/>
-          <p:nvPr/>
-        </p:nvSpPr>
-        <p:spPr>
-          <a:xfrm>
-            <a:off x="6400800" y="2029968"/>
-            <a:ext cx="2194560" cy="457200"/>
-          </a:xfrm>
-          <a:prstGeom prst="rect">
-            <a:avLst/>
-          </a:prstGeom>
-          <a:noFill/>
-        </p:spPr>
-        <p:txBody>
-          <a:bodyPr wrap="square" anchor="ctr" lIns="0" rIns="0" tIns="0" bIns="0">
-            <a:spAutoFit/>
-          </a:bodyPr>
-          <a:lstStyle/>
-          <a:p>
-            <a:pPr algn="l">
-              <a:lnSpc>
-                <a:spcPct val="100000"/>
-              </a:lnSpc>
-              <a:spcBef>
-                <a:spcPts val="0"/>
-              </a:spcBef>
-              <a:spcAft>
-                <a:spcPts val="400"/>
-              </a:spcAft>
-            </a:pPr>
-            <a:r>
-              <a:rPr sz="1700" b="1" i="0">
-                <a:solidFill>
-                  <a:srgbClr val="FFFFFF"/>
-                </a:solidFill>
-                <a:latin typeface="Calibri"/>
-              </a:rPr>
-              <a:t>Collider</a:t>
-            </a:r>
-          </a:p>
-        </p:txBody>
-      </p:sp>
-      <p:sp>
-        <p:nvSpPr>
-          <p:cNvPr id="18" name="TextBox 17"/>
-          <p:cNvSpPr txBox="1"/>
-          <p:nvPr/>
-        </p:nvSpPr>
-        <p:spPr>
-          <a:xfrm>
-            <a:off x="6400800" y="2697480"/>
-            <a:ext cx="2194560" cy="457200"/>
-          </a:xfrm>
-          <a:prstGeom prst="rect">
-            <a:avLst/>
-          </a:prstGeom>
-          <a:noFill/>
-        </p:spPr>
-        <p:txBody>
-          <a:bodyPr wrap="square" anchor="t" lIns="0" rIns="0" tIns="0" bIns="0">
-            <a:spAutoFit/>
-          </a:bodyPr>
-          <a:lstStyle/>
-          <a:p>
-            <a:pPr algn="l">
-              <a:lnSpc>
-                <a:spcPct val="100000"/>
-              </a:lnSpc>
-              <a:spcBef>
-                <a:spcPts val="0"/>
-              </a:spcBef>
-              <a:spcAft>
-                <a:spcPts val="400"/>
-              </a:spcAft>
-            </a:pPr>
-            <a:r>
-              <a:rPr sz="1400" b="1" i="1">
-                <a:solidFill>
-                  <a:srgbClr val="E9A23B"/>
-                </a:solidFill>
-                <a:latin typeface="Calibri"/>
-              </a:rPr>
-              <a:t>common effect</a:t>
-            </a:r>
-          </a:p>
-        </p:txBody>
-      </p:sp>
-      <p:sp>
-        <p:nvSpPr>
-          <p:cNvPr id="19" name="TextBox 18"/>
-          <p:cNvSpPr txBox="1"/>
-          <p:nvPr/>
-        </p:nvSpPr>
-        <p:spPr>
-          <a:xfrm>
-            <a:off x="6400800" y="3200400"/>
-            <a:ext cx="2194560" cy="2743200"/>
-          </a:xfrm>
-          <a:prstGeom prst="rect">
-            <a:avLst/>
-          </a:prstGeom>
-          <a:noFill/>
-        </p:spPr>
-        <p:txBody>
-          <a:bodyPr wrap="square" anchor="t" lIns="0" rIns="0" tIns="0" bIns="0">
-            <a:spAutoFit/>
-          </a:bodyPr>
-          <a:lstStyle/>
-          <a:p>
-            <a:pPr algn="l">
-              <a:lnSpc>
-                <a:spcPct val="100000"/>
-              </a:lnSpc>
-              <a:spcBef>
-                <a:spcPts val="0"/>
-              </a:spcBef>
-              <a:spcAft>
-                <a:spcPts val="700"/>
-              </a:spcAft>
-            </a:pPr>
-            <a:r>
-              <a:rPr sz="1800" b="1" i="0">
-                <a:solidFill>
-                  <a:srgbClr val="E9A23B"/>
-                </a:solidFill>
-                <a:latin typeface="Calibri"/>
-              </a:rPr>
-              <a:t>—  </a:t>
-            </a:r>
-            <a:r>
-              <a:rPr sz="1800" b="0" i="0">
-                <a:solidFill>
-                  <a:srgbClr val="222732"/>
-                </a:solidFill>
-                <a:latin typeface="Calibri"/>
-              </a:rPr>
-              <a:t>X → K ← Y.</a:t>
-            </a:r>
-          </a:p>
-          <a:p>
-            <a:pPr algn="l">
-              <a:lnSpc>
-                <a:spcPct val="100000"/>
-              </a:lnSpc>
-              <a:spcBef>
-                <a:spcPts val="0"/>
-              </a:spcBef>
-              <a:spcAft>
-                <a:spcPts val="700"/>
-              </a:spcAft>
-            </a:pPr>
-            <a:r>
-              <a:rPr sz="1800" b="1" i="0">
-                <a:solidFill>
-                  <a:srgbClr val="E9A23B"/>
-                </a:solidFill>
-                <a:latin typeface="Calibri"/>
-              </a:rPr>
-              <a:t>—  </a:t>
-            </a:r>
-            <a:r>
-              <a:rPr sz="1800" b="0" i="0">
-                <a:solidFill>
-                  <a:srgbClr val="222732"/>
-                </a:solidFill>
-                <a:latin typeface="Calibri"/>
-              </a:rPr>
-              <a:t>Already blocked.</a:t>
-            </a:r>
-          </a:p>
-          <a:p>
-            <a:pPr algn="l">
-              <a:lnSpc>
-                <a:spcPct val="100000"/>
-              </a:lnSpc>
-              <a:spcBef>
-                <a:spcPts val="0"/>
-              </a:spcBef>
-              <a:spcAft>
-                <a:spcPts val="700"/>
-              </a:spcAft>
-            </a:pPr>
-            <a:r>
-              <a:rPr sz="1800" b="1" i="0">
-                <a:solidFill>
-                  <a:srgbClr val="E9A23B"/>
-                </a:solidFill>
-                <a:latin typeface="Calibri"/>
-              </a:rPr>
-              <a:t>—  </a:t>
-            </a:r>
-            <a:r>
-              <a:rPr sz="1800" b="0" i="0">
-                <a:solidFill>
-                  <a:srgbClr val="222732"/>
-                </a:solidFill>
-                <a:latin typeface="Calibri"/>
-              </a:rPr>
-              <a:t>DON'T — opens a fake path.</a:t>
-            </a:r>
-          </a:p>
-        </p:txBody>
-      </p:sp>
-      <p:sp>
-        <p:nvSpPr>
-          <p:cNvPr id="20" name="Rectangle 19"/>
-          <p:cNvSpPr/>
-          <p:nvPr/>
-        </p:nvSpPr>
-        <p:spPr>
-          <a:xfrm>
-            <a:off x="9052560" y="1920240"/>
-            <a:ext cx="2560320" cy="4297680"/>
-          </a:xfrm>
-          <a:prstGeom prst="rect">
-            <a:avLst/>
-          </a:prstGeom>
-          <a:solidFill>
-            <a:srgbClr val="ECEEF2"/>
-          </a:solidFill>
-          <a:ln>
-            <a:noFill/>
-          </a:ln>
-          <a:effectLst/>
-        </p:spPr>
-        <p:style>
-          <a:lnRef idx="1">
-            <a:schemeClr val="accent1"/>
-          </a:lnRef>
-          <a:fillRef idx="3">
-            <a:schemeClr val="accent1"/>
-          </a:fillRef>
-          <a:effectRef idx="2">
-            <a:schemeClr val="accent1"/>
-          </a:effectRef>
-          <a:fontRef idx="minor">
-            <a:schemeClr val="lt1"/>
-          </a:fontRef>
-        </p:style>
-        <p:txBody>
-          <a:bodyPr rtlCol="0" anchor="ctr"/>
-          <a:lstStyle/>
-          <a:p>
-            <a:pPr algn="ctr"/>
-          </a:p>
-        </p:txBody>
-      </p:sp>
-      <p:sp>
-        <p:nvSpPr>
-          <p:cNvPr id="21" name="Rectangle 20"/>
-          <p:cNvSpPr/>
-          <p:nvPr/>
-        </p:nvSpPr>
-        <p:spPr>
-          <a:xfrm>
-            <a:off x="9052560" y="1920240"/>
-            <a:ext cx="2560320" cy="640080"/>
-          </a:xfrm>
-          <a:prstGeom prst="rect">
-            <a:avLst/>
-          </a:prstGeom>
-          <a:solidFill>
-            <a:srgbClr val="2F6DB5"/>
-          </a:solidFill>
-          <a:ln>
-            <a:noFill/>
-          </a:ln>
-          <a:effectLst/>
-        </p:spPr>
-        <p:style>
-          <a:lnRef idx="1">
-            <a:schemeClr val="accent1"/>
-          </a:lnRef>
-          <a:fillRef idx="3">
-            <a:schemeClr val="accent1"/>
-          </a:fillRef>
-          <a:effectRef idx="2">
-            <a:schemeClr val="accent1"/>
-          </a:effectRef>
-          <a:fontRef idx="minor">
-            <a:schemeClr val="lt1"/>
-          </a:fontRef>
-        </p:style>
-        <p:txBody>
-          <a:bodyPr rtlCol="0" anchor="ctr"/>
-          <a:lstStyle/>
-          <a:p>
-            <a:pPr algn="ctr"/>
-          </a:p>
-        </p:txBody>
-      </p:sp>
-      <p:sp>
-        <p:nvSpPr>
-          <p:cNvPr id="22" name="TextBox 21"/>
-          <p:cNvSpPr txBox="1"/>
-          <p:nvPr/>
-        </p:nvSpPr>
-        <p:spPr>
-          <a:xfrm>
-            <a:off x="9235440" y="2029968"/>
-            <a:ext cx="2194560" cy="457200"/>
-          </a:xfrm>
-          <a:prstGeom prst="rect">
-            <a:avLst/>
-          </a:prstGeom>
-          <a:noFill/>
-        </p:spPr>
-        <p:txBody>
-          <a:bodyPr wrap="square" anchor="ctr" lIns="0" rIns="0" tIns="0" bIns="0">
-            <a:spAutoFit/>
-          </a:bodyPr>
-          <a:lstStyle/>
-          <a:p>
-            <a:pPr algn="l">
-              <a:lnSpc>
-                <a:spcPct val="100000"/>
-              </a:lnSpc>
-              <a:spcBef>
-                <a:spcPts val="0"/>
-              </a:spcBef>
-              <a:spcAft>
-                <a:spcPts val="400"/>
-              </a:spcAft>
-            </a:pPr>
-            <a:r>
-              <a:rPr sz="1700" b="1" i="0">
-                <a:solidFill>
-                  <a:srgbClr val="FFFFFF"/>
-                </a:solidFill>
-                <a:latin typeface="Calibri"/>
-              </a:rPr>
-              <a:t>Neutral</a:t>
-            </a:r>
-          </a:p>
-        </p:txBody>
-      </p:sp>
-      <p:sp>
-        <p:nvSpPr>
-          <p:cNvPr id="23" name="TextBox 22"/>
-          <p:cNvSpPr txBox="1"/>
-          <p:nvPr/>
-        </p:nvSpPr>
-        <p:spPr>
-          <a:xfrm>
-            <a:off x="9235440" y="2697480"/>
-            <a:ext cx="2194560" cy="457200"/>
-          </a:xfrm>
-          <a:prstGeom prst="rect">
-            <a:avLst/>
-          </a:prstGeom>
-          <a:noFill/>
-        </p:spPr>
-        <p:txBody>
-          <a:bodyPr wrap="square" anchor="t" lIns="0" rIns="0" tIns="0" bIns="0">
-            <a:spAutoFit/>
-          </a:bodyPr>
-          <a:lstStyle/>
-          <a:p>
-            <a:pPr algn="l">
-              <a:lnSpc>
-                <a:spcPct val="100000"/>
-              </a:lnSpc>
-              <a:spcBef>
-                <a:spcPts val="0"/>
-              </a:spcBef>
-              <a:spcAft>
-                <a:spcPts val="400"/>
-              </a:spcAft>
-            </a:pPr>
-            <a:r>
-              <a:rPr sz="1400" b="1" i="1">
-                <a:solidFill>
-                  <a:srgbClr val="2F6DB5"/>
-                </a:solidFill>
-                <a:latin typeface="Calibri"/>
-              </a:rPr>
-              <a:t>outcome predictor</a:t>
-            </a:r>
-          </a:p>
-        </p:txBody>
-      </p:sp>
-      <p:sp>
-        <p:nvSpPr>
-          <p:cNvPr id="24" name="TextBox 23"/>
-          <p:cNvSpPr txBox="1"/>
-          <p:nvPr/>
-        </p:nvSpPr>
-        <p:spPr>
-          <a:xfrm>
-            <a:off x="9235440" y="3200400"/>
-            <a:ext cx="2194560" cy="2743200"/>
-          </a:xfrm>
-          <a:prstGeom prst="rect">
-            <a:avLst/>
-          </a:prstGeom>
-          <a:noFill/>
-        </p:spPr>
-        <p:txBody>
-          <a:bodyPr wrap="square" anchor="t" lIns="0" rIns="0" tIns="0" bIns="0">
-            <a:spAutoFit/>
-          </a:bodyPr>
-          <a:lstStyle/>
-          <a:p>
-            <a:pPr algn="l">
-              <a:lnSpc>
-                <a:spcPct val="100000"/>
-              </a:lnSpc>
-              <a:spcBef>
-                <a:spcPts val="0"/>
-              </a:spcBef>
-              <a:spcAft>
-                <a:spcPts val="700"/>
-              </a:spcAft>
-            </a:pPr>
-            <a:r>
-              <a:rPr sz="1800" b="1" i="0">
-                <a:solidFill>
-                  <a:srgbClr val="E9A23B"/>
-                </a:solidFill>
-                <a:latin typeface="Calibri"/>
-              </a:rPr>
-              <a:t>—  </a:t>
-            </a:r>
-            <a:r>
-              <a:rPr sz="1800" b="0" i="0">
-                <a:solidFill>
-                  <a:srgbClr val="222732"/>
-                </a:solidFill>
-                <a:latin typeface="Calibri"/>
-              </a:rPr>
-              <a:t>Z → Y only, not → X.</a:t>
-            </a:r>
-          </a:p>
-          <a:p>
-            <a:pPr algn="l">
-              <a:lnSpc>
-                <a:spcPct val="100000"/>
-              </a:lnSpc>
-              <a:spcBef>
-                <a:spcPts val="0"/>
-              </a:spcBef>
-              <a:spcAft>
-                <a:spcPts val="700"/>
-              </a:spcAft>
-            </a:pPr>
-            <a:r>
-              <a:rPr sz="1800" b="1" i="0">
-                <a:solidFill>
-                  <a:srgbClr val="E9A23B"/>
-                </a:solidFill>
-                <a:latin typeface="Calibri"/>
-              </a:rPr>
-              <a:t>—  </a:t>
-            </a:r>
-            <a:r>
-              <a:rPr sz="1800" b="0" i="0">
-                <a:solidFill>
-                  <a:srgbClr val="222732"/>
-                </a:solidFill>
-                <a:latin typeface="Calibri"/>
-              </a:rPr>
-              <a:t>Off every back-door.</a:t>
-            </a:r>
-          </a:p>
-          <a:p>
-            <a:pPr algn="l">
-              <a:lnSpc>
-                <a:spcPct val="100000"/>
-              </a:lnSpc>
-              <a:spcBef>
-                <a:spcPts val="0"/>
-              </a:spcBef>
-              <a:spcAft>
-                <a:spcPts val="700"/>
-              </a:spcAft>
-            </a:pPr>
-            <a:r>
-              <a:rPr sz="1800" b="1" i="0">
-                <a:solidFill>
-                  <a:srgbClr val="E9A23B"/>
-                </a:solidFill>
-                <a:latin typeface="Calibri"/>
-              </a:rPr>
-              <a:t>—  </a:t>
-            </a:r>
-            <a:r>
-              <a:rPr sz="1800" b="0" i="0">
-                <a:solidFill>
-                  <a:srgbClr val="222732"/>
-                </a:solidFill>
-                <a:latin typeface="Calibri"/>
-              </a:rPr>
-              <a:t>Optional — lowers variance.</a:t>
-            </a:r>
-          </a:p>
-        </p:txBody>
-      </p:sp>
-      <p:sp>
-        <p:nvSpPr>
-          <p:cNvPr id="25" name="Rectangle 24"/>
+              <a:t>Structure, not timing, decides. Read the role off the graph before you touch the regression.</a:t>
+            </a:r>
+          </a:p>
+        </p:txBody>
+      </p:sp>
+      <p:sp>
+        <p:nvSpPr>
+          <p:cNvPr id="7" name="Rectangle 6"/>
           <p:cNvSpPr/>
           <p:nvPr/>
         </p:nvSpPr>
@@ -6426,7 +5762,7 @@
       </p:sp>
       <p:sp>
         <p:nvSpPr>
-          <p:cNvPr id="26" name="TextBox 25"/>
+          <p:cNvPr id="8" name="TextBox 7"/>
           <p:cNvSpPr txBox="1"/>
           <p:nvPr/>
         </p:nvSpPr>
@@ -6471,7 +5807,7 @@
       </p:sp>
       <p:sp>
         <p:nvSpPr>
-          <p:cNvPr id="27" name="TextBox 26"/>
+          <p:cNvPr id="9" name="TextBox 8"/>
           <p:cNvSpPr txBox="1"/>
           <p:nvPr/>
         </p:nvSpPr>

</xml_diff>